<commit_message>
Restructure external (Open Door) section with Tier targets and offering flow
Co-Authored-By: Claude Opus 5.5 <noreply@anthropic.com>
Claude-Session: https://claude.ai/code/session_01Jtai5qv53qCamJqUYDvcNe
</commit_message>
<xml_diff>
--- a/AX_Consulting_Team_Direction.pptx
+++ b/AX_Consulting_Team_Direction.pptx
@@ -107,7 +107,7 @@
   <p:extLst>
     <p:ext uri="{521415D9-36F7-43E2-AB2F-B90AF26B5E84}">
       <p14:sectionLst xmlns:p14="http://schemas.microsoft.com/office/powerpoint/2010/main">
-        <p14:section name="Next INWAYIN" id="{ca189300-0f94-f870-9cb3-b65ec289870c}">
+        <p14:section name="Next INWAYIN" id="{f387f169-248a-02b0-ac64-17d593ccadd2}">
           <p14:sldIdLst>
             <p14:sldId id="256"/>
           </p14:sldIdLst>
@@ -516,7 +516,7 @@
           <a:p>
             <a:r>
               <a:rPr lang="en-US" dirty="0"/>
-              <a:t>구조: 세 번째 참고 장표(To Do List) 형식 - 진회색 배너 + 라벨/불릿 블록 + 노란 강조 연결문. 그룹사 ①Blue Print(ex. K7) ②AX Inno Camp ③FDE 실행(FDE Pod 도식: 3단계·Gate·자산화 순환). 대외: 전략영업 고객사 Pool → 역량 진단·Tier 그룹화(시스템 현대화/데이터 수준) → Tier별 선제안(개발·SaaS·클라우드 구독 연계) → 도입 시점 AI과제 접목으로 사업 범위 확장·수주 기여. 왼쪽 표 수치는 원본 기준(과제 상세 정리 중).</a:t>
+              <a:t>구조: 세 번째 참고 장표(To Do List) 형식 - 진회색 배너 + 라벨/불릿 블록 + 노란 강조 연결문. 그룹사 ①Blue Print(ex. K7) ②AX Inno Camp ③FDE 실행(FDE Pod 도식: 3단계·Gate·자산화 순환). 대외: 그룹사 검증 사례(Client Zero) 레퍼런스 기반 전략영업 고객사 선제안. 역량 진단·Tier화(Tier1 차세대시스템 도입 예정-공항철도 등, 1년 내 완료 / Tier2 데이터플랫폼·클라우드 예정-파리크라상 등) → Tier별 선제안(AX Quick Scan 2~4주 → 시스템+AI 결합 제안·구축 → 구축 후 AI 단계별 확장 → 표준 축적·확산). KPI: 결합 수주 건수·금액. 왼쪽 표 수치는 원본 기준(과제 상세 정리 중).</a:t>
             </a:r>
             <a:endParaRPr lang="en-US" dirty="0"/>
           </a:p>
@@ -6112,7 +6112,7 @@
                 <a:ea typeface="맑은 고딕" pitchFamily="34" charset="-122"/>
                 <a:cs typeface="맑은 고딕" pitchFamily="34" charset="-120"/>
               </a:rPr>
-              <a:t>   “전략영업 고객사 Pool 기반 선제안”</a:t>
+              <a:t>   “그룹사 검증 사례(Client Zero) 기반 전략영업 고객사 선제안”</a:t>
             </a:r>
             <a:endParaRPr lang="en-US" sz="1350" dirty="0"/>
           </a:p>
@@ -6282,7 +6282,7 @@
                 <a:ea typeface="맑은 고딕" pitchFamily="34" charset="-122"/>
                 <a:cs typeface="맑은 고딕" pitchFamily="34" charset="-120"/>
               </a:rPr>
-              <a:t>수주(예정) 그룹사·고객사 역량 진단</a:t>
+              <a:t>시스템·데이터 수준 진단 → Tier 구분</a:t>
             </a:r>
             <a:endParaRPr lang="en-US" sz="1000" dirty="0"/>
           </a:p>
@@ -6346,7 +6346,7 @@
                 <a:ea typeface="맑은 고딕" pitchFamily="34" charset="-122"/>
                 <a:cs typeface="맑은 고딕" pitchFamily="34" charset="-120"/>
               </a:rPr>
-              <a:t>시스템 현대화 / 데이터 수준 평가</a:t>
+              <a:t>Tier1 : 차세대 도입 (공항철도 등)</a:t>
             </a:r>
             <a:endParaRPr lang="en-US" sz="1000" dirty="0"/>
           </a:p>
@@ -6410,7 +6410,7 @@
                 <a:ea typeface="맑은 고딕" pitchFamily="34" charset="-122"/>
                 <a:cs typeface="맑은 고딕" pitchFamily="34" charset="-120"/>
               </a:rPr>
-              <a:t>활용 가능 수준별 Tier 그룹 구분</a:t>
+              <a:t>Tier2 : 클라우드 (파리크라상 등)</a:t>
             </a:r>
             <a:endParaRPr lang="en-US" sz="1000" dirty="0"/>
           </a:p>
@@ -6580,7 +6580,7 @@
                 <a:ea typeface="맑은 고딕" pitchFamily="34" charset="-122"/>
                 <a:cs typeface="맑은 고딕" pitchFamily="34" charset="-120"/>
               </a:rPr>
-              <a:t>개발 · SaaS · 클라우드 구독 사업 연계</a:t>
+              <a:t>AX Quick Scan(2~4주) 과제 발굴</a:t>
             </a:r>
             <a:endParaRPr lang="en-US" sz="1000" dirty="0"/>
           </a:p>
@@ -6644,7 +6644,7 @@
                 <a:ea typeface="맑은 고딕" pitchFamily="34" charset="-122"/>
                 <a:cs typeface="맑은 고딕" pitchFamily="34" charset="-120"/>
               </a:rPr>
-              <a:t>도입 시점에 AI과제 접목 제안</a:t>
+              <a:t>시스템+AI 결합 제안·구축</a:t>
             </a:r>
             <a:endParaRPr lang="en-US" sz="1000" dirty="0"/>
           </a:p>
@@ -6708,7 +6708,7 @@
                 <a:ea typeface="맑은 고딕" pitchFamily="34" charset="-122"/>
                 <a:cs typeface="맑은 고딕" pitchFamily="34" charset="-120"/>
               </a:rPr>
-              <a:t>시스템 + AI과제로 사업 범위 확대</a:t>
+              <a:t>구축 후 AI 단계 확장·표준화</a:t>
             </a:r>
             <a:endParaRPr lang="en-US" sz="1000" dirty="0"/>
           </a:p>
@@ -6792,6 +6792,23 @@
                 <a:cs typeface="맑은 고딕" pitchFamily="34" charset="-120"/>
               </a:rPr>
               <a:t>사업 범위 확장 · 수주 기여</a:t>
+            </a:r>
+            <a:pPr algn="ctr" indent="0" marL="0">
+              <a:buNone/>
+            </a:pPr>
+            <a:r>
+              <a:rPr lang="en-US" sz="1150" b="1" dirty="0">
+                <a:solidFill>
+                  <a:srgbClr val="000000"/>
+                </a:solidFill>
+                <a:highlight>
+                  <a:srgbClr val="FFFF00"/>
+                </a:highlight>
+                <a:latin typeface="맑은 고딕" pitchFamily="34" charset="0"/>
+                <a:ea typeface="맑은 고딕" pitchFamily="34" charset="-122"/>
+                <a:cs typeface="맑은 고딕" pitchFamily="34" charset="-120"/>
+              </a:rPr>
+              <a:t> (KPI : 결합 수주 건수·금액)</a:t>
             </a:r>
             <a:endParaRPr lang="en-US" sz="1150" dirty="0"/>
           </a:p>

</xml_diff>